<commit_message>
2022-08-08 End of day file push
</commit_message>
<xml_diff>
--- a/Doomsday Counter/buttons.pptx
+++ b/Doomsday Counter/buttons.pptx
@@ -8,6 +8,7 @@
     <p:sldId id="256" r:id="rId2"/>
     <p:sldId id="257" r:id="rId3"/>
     <p:sldId id="258" r:id="rId4"/>
+    <p:sldId id="259" r:id="rId5"/>
   </p:sldIdLst>
   <p:sldSz cx="9144000" cy="6858000" type="screen4x3"/>
   <p:notesSz cx="6858000" cy="9144000"/>
@@ -106,6 +107,22 @@
       </a:defRPr>
     </a:lvl9pPr>
   </p:defaultTextStyle>
+  <p:extLst>
+    <p:ext uri="{EFAFB233-063F-42B5-8137-9DF3F51BA10A}">
+      <p15:sldGuideLst xmlns:p15="http://schemas.microsoft.com/office/powerpoint/2012/main">
+        <p15:guide id="1" orient="horz" pos="2160">
+          <p15:clr>
+            <a:srgbClr val="A4A3A4"/>
+          </p15:clr>
+        </p15:guide>
+        <p15:guide id="2" pos="2880">
+          <p15:clr>
+            <a:srgbClr val="A4A3A4"/>
+          </p15:clr>
+        </p15:guide>
+      </p15:sldGuideLst>
+    </p:ext>
+  </p:extLst>
 </p:presentation>
 </file>
 
@@ -147,10 +164,9 @@
           <a:lstStyle/>
           <a:p>
             <a:r>
-              <a:rPr lang="en-US" smtClean="0"/>
+              <a:rPr lang="en-US"/>
               <a:t>Click to edit Master title style</a:t>
             </a:r>
-            <a:endParaRPr lang="en-US"/>
           </a:p>
         </p:txBody>
       </p:sp>
@@ -266,10 +282,9 @@
           </a:lstStyle>
           <a:p>
             <a:r>
-              <a:rPr lang="en-US" smtClean="0"/>
+              <a:rPr lang="en-US"/>
               <a:t>Click to edit Master subtitle style</a:t>
             </a:r>
-            <a:endParaRPr lang="en-US"/>
           </a:p>
         </p:txBody>
       </p:sp>
@@ -290,7 +305,7 @@
           <a:p>
             <a:fld id="{72CDDEA1-CAA3-44E9-BD20-01615CE14A03}" type="datetimeFigureOut">
               <a:rPr lang="en-US" smtClean="0"/>
-              <a:t>7/25/2022</a:t>
+              <a:t>8/3/2022</a:t>
             </a:fld>
             <a:endParaRPr lang="en-US"/>
           </a:p>
@@ -379,10 +394,9 @@
           <a:lstStyle/>
           <a:p>
             <a:r>
-              <a:rPr lang="en-US" smtClean="0"/>
+              <a:rPr lang="en-US"/>
               <a:t>Click to edit Master title style</a:t>
             </a:r>
-            <a:endParaRPr lang="en-US"/>
           </a:p>
         </p:txBody>
       </p:sp>
@@ -403,38 +417,37 @@
           <a:p>
             <a:pPr lvl="0"/>
             <a:r>
-              <a:rPr lang="en-US" smtClean="0"/>
+              <a:rPr lang="en-US"/>
               <a:t>Click to edit Master text styles</a:t>
             </a:r>
           </a:p>
           <a:p>
             <a:pPr lvl="1"/>
             <a:r>
-              <a:rPr lang="en-US" smtClean="0"/>
+              <a:rPr lang="en-US"/>
               <a:t>Second level</a:t>
             </a:r>
           </a:p>
           <a:p>
             <a:pPr lvl="2"/>
             <a:r>
-              <a:rPr lang="en-US" smtClean="0"/>
+              <a:rPr lang="en-US"/>
               <a:t>Third level</a:t>
             </a:r>
           </a:p>
           <a:p>
             <a:pPr lvl="3"/>
             <a:r>
-              <a:rPr lang="en-US" smtClean="0"/>
+              <a:rPr lang="en-US"/>
               <a:t>Fourth level</a:t>
             </a:r>
           </a:p>
           <a:p>
             <a:pPr lvl="4"/>
             <a:r>
-              <a:rPr lang="en-US" smtClean="0"/>
+              <a:rPr lang="en-US"/>
               <a:t>Fifth level</a:t>
             </a:r>
-            <a:endParaRPr lang="en-US"/>
           </a:p>
         </p:txBody>
       </p:sp>
@@ -455,7 +468,7 @@
           <a:p>
             <a:fld id="{72CDDEA1-CAA3-44E9-BD20-01615CE14A03}" type="datetimeFigureOut">
               <a:rPr lang="en-US" smtClean="0"/>
-              <a:t>7/25/2022</a:t>
+              <a:t>8/3/2022</a:t>
             </a:fld>
             <a:endParaRPr lang="en-US"/>
           </a:p>
@@ -549,10 +562,9 @@
           <a:lstStyle/>
           <a:p>
             <a:r>
-              <a:rPr lang="en-US" smtClean="0"/>
+              <a:rPr lang="en-US"/>
               <a:t>Click to edit Master title style</a:t>
             </a:r>
-            <a:endParaRPr lang="en-US"/>
           </a:p>
         </p:txBody>
       </p:sp>
@@ -578,38 +590,37 @@
           <a:p>
             <a:pPr lvl="0"/>
             <a:r>
-              <a:rPr lang="en-US" smtClean="0"/>
+              <a:rPr lang="en-US"/>
               <a:t>Click to edit Master text styles</a:t>
             </a:r>
           </a:p>
           <a:p>
             <a:pPr lvl="1"/>
             <a:r>
-              <a:rPr lang="en-US" smtClean="0"/>
+              <a:rPr lang="en-US"/>
               <a:t>Second level</a:t>
             </a:r>
           </a:p>
           <a:p>
             <a:pPr lvl="2"/>
             <a:r>
-              <a:rPr lang="en-US" smtClean="0"/>
+              <a:rPr lang="en-US"/>
               <a:t>Third level</a:t>
             </a:r>
           </a:p>
           <a:p>
             <a:pPr lvl="3"/>
             <a:r>
-              <a:rPr lang="en-US" smtClean="0"/>
+              <a:rPr lang="en-US"/>
               <a:t>Fourth level</a:t>
             </a:r>
           </a:p>
           <a:p>
             <a:pPr lvl="4"/>
             <a:r>
-              <a:rPr lang="en-US" smtClean="0"/>
+              <a:rPr lang="en-US"/>
               <a:t>Fifth level</a:t>
             </a:r>
-            <a:endParaRPr lang="en-US"/>
           </a:p>
         </p:txBody>
       </p:sp>
@@ -630,7 +641,7 @@
           <a:p>
             <a:fld id="{72CDDEA1-CAA3-44E9-BD20-01615CE14A03}" type="datetimeFigureOut">
               <a:rPr lang="en-US" smtClean="0"/>
-              <a:t>7/25/2022</a:t>
+              <a:t>8/3/2022</a:t>
             </a:fld>
             <a:endParaRPr lang="en-US"/>
           </a:p>
@@ -719,10 +730,9 @@
           <a:lstStyle/>
           <a:p>
             <a:r>
-              <a:rPr lang="en-US" smtClean="0"/>
+              <a:rPr lang="en-US"/>
               <a:t>Click to edit Master title style</a:t>
             </a:r>
-            <a:endParaRPr lang="en-US"/>
           </a:p>
         </p:txBody>
       </p:sp>
@@ -743,38 +753,37 @@
           <a:p>
             <a:pPr lvl="0"/>
             <a:r>
-              <a:rPr lang="en-US" smtClean="0"/>
+              <a:rPr lang="en-US"/>
               <a:t>Click to edit Master text styles</a:t>
             </a:r>
           </a:p>
           <a:p>
             <a:pPr lvl="1"/>
             <a:r>
-              <a:rPr lang="en-US" smtClean="0"/>
+              <a:rPr lang="en-US"/>
               <a:t>Second level</a:t>
             </a:r>
           </a:p>
           <a:p>
             <a:pPr lvl="2"/>
             <a:r>
-              <a:rPr lang="en-US" smtClean="0"/>
+              <a:rPr lang="en-US"/>
               <a:t>Third level</a:t>
             </a:r>
           </a:p>
           <a:p>
             <a:pPr lvl="3"/>
             <a:r>
-              <a:rPr lang="en-US" smtClean="0"/>
+              <a:rPr lang="en-US"/>
               <a:t>Fourth level</a:t>
             </a:r>
           </a:p>
           <a:p>
             <a:pPr lvl="4"/>
             <a:r>
-              <a:rPr lang="en-US" smtClean="0"/>
+              <a:rPr lang="en-US"/>
               <a:t>Fifth level</a:t>
             </a:r>
-            <a:endParaRPr lang="en-US"/>
           </a:p>
         </p:txBody>
       </p:sp>
@@ -795,7 +804,7 @@
           <a:p>
             <a:fld id="{72CDDEA1-CAA3-44E9-BD20-01615CE14A03}" type="datetimeFigureOut">
               <a:rPr lang="en-US" smtClean="0"/>
-              <a:t>7/25/2022</a:t>
+              <a:t>8/3/2022</a:t>
             </a:fld>
             <a:endParaRPr lang="en-US"/>
           </a:p>
@@ -893,10 +902,9 @@
           </a:lstStyle>
           <a:p>
             <a:r>
-              <a:rPr lang="en-US" smtClean="0"/>
+              <a:rPr lang="en-US"/>
               <a:t>Click to edit Master title style</a:t>
             </a:r>
-            <a:endParaRPr lang="en-US"/>
           </a:p>
         </p:txBody>
       </p:sp>
@@ -1013,7 +1021,7 @@
           <a:p>
             <a:pPr lvl="0"/>
             <a:r>
-              <a:rPr lang="en-US" smtClean="0"/>
+              <a:rPr lang="en-US"/>
               <a:t>Click to edit Master text styles</a:t>
             </a:r>
           </a:p>
@@ -1036,7 +1044,7 @@
           <a:p>
             <a:fld id="{72CDDEA1-CAA3-44E9-BD20-01615CE14A03}" type="datetimeFigureOut">
               <a:rPr lang="en-US" smtClean="0"/>
-              <a:t>7/25/2022</a:t>
+              <a:t>8/3/2022</a:t>
             </a:fld>
             <a:endParaRPr lang="en-US"/>
           </a:p>
@@ -1125,10 +1133,9 @@
           <a:lstStyle/>
           <a:p>
             <a:r>
-              <a:rPr lang="en-US" smtClean="0"/>
+              <a:rPr lang="en-US"/>
               <a:t>Click to edit Master title style</a:t>
             </a:r>
-            <a:endParaRPr lang="en-US"/>
           </a:p>
         </p:txBody>
       </p:sp>
@@ -1182,38 +1189,37 @@
           <a:p>
             <a:pPr lvl="0"/>
             <a:r>
-              <a:rPr lang="en-US" smtClean="0"/>
+              <a:rPr lang="en-US"/>
               <a:t>Click to edit Master text styles</a:t>
             </a:r>
           </a:p>
           <a:p>
             <a:pPr lvl="1"/>
             <a:r>
-              <a:rPr lang="en-US" smtClean="0"/>
+              <a:rPr lang="en-US"/>
               <a:t>Second level</a:t>
             </a:r>
           </a:p>
           <a:p>
             <a:pPr lvl="2"/>
             <a:r>
-              <a:rPr lang="en-US" smtClean="0"/>
+              <a:rPr lang="en-US"/>
               <a:t>Third level</a:t>
             </a:r>
           </a:p>
           <a:p>
             <a:pPr lvl="3"/>
             <a:r>
-              <a:rPr lang="en-US" smtClean="0"/>
+              <a:rPr lang="en-US"/>
               <a:t>Fourth level</a:t>
             </a:r>
           </a:p>
           <a:p>
             <a:pPr lvl="4"/>
             <a:r>
-              <a:rPr lang="en-US" smtClean="0"/>
+              <a:rPr lang="en-US"/>
               <a:t>Fifth level</a:t>
             </a:r>
-            <a:endParaRPr lang="en-US"/>
           </a:p>
         </p:txBody>
       </p:sp>
@@ -1267,38 +1273,37 @@
           <a:p>
             <a:pPr lvl="0"/>
             <a:r>
-              <a:rPr lang="en-US" smtClean="0"/>
+              <a:rPr lang="en-US"/>
               <a:t>Click to edit Master text styles</a:t>
             </a:r>
           </a:p>
           <a:p>
             <a:pPr lvl="1"/>
             <a:r>
-              <a:rPr lang="en-US" smtClean="0"/>
+              <a:rPr lang="en-US"/>
               <a:t>Second level</a:t>
             </a:r>
           </a:p>
           <a:p>
             <a:pPr lvl="2"/>
             <a:r>
-              <a:rPr lang="en-US" smtClean="0"/>
+              <a:rPr lang="en-US"/>
               <a:t>Third level</a:t>
             </a:r>
           </a:p>
           <a:p>
             <a:pPr lvl="3"/>
             <a:r>
-              <a:rPr lang="en-US" smtClean="0"/>
+              <a:rPr lang="en-US"/>
               <a:t>Fourth level</a:t>
             </a:r>
           </a:p>
           <a:p>
             <a:pPr lvl="4"/>
             <a:r>
-              <a:rPr lang="en-US" smtClean="0"/>
+              <a:rPr lang="en-US"/>
               <a:t>Fifth level</a:t>
             </a:r>
-            <a:endParaRPr lang="en-US"/>
           </a:p>
         </p:txBody>
       </p:sp>
@@ -1319,7 +1324,7 @@
           <a:p>
             <a:fld id="{72CDDEA1-CAA3-44E9-BD20-01615CE14A03}" type="datetimeFigureOut">
               <a:rPr lang="en-US" smtClean="0"/>
-              <a:t>7/25/2022</a:t>
+              <a:t>8/3/2022</a:t>
             </a:fld>
             <a:endParaRPr lang="en-US"/>
           </a:p>
@@ -1412,10 +1417,9 @@
           </a:lstStyle>
           <a:p>
             <a:r>
-              <a:rPr lang="en-US" smtClean="0"/>
+              <a:rPr lang="en-US"/>
               <a:t>Click to edit Master title style</a:t>
             </a:r>
-            <a:endParaRPr lang="en-US"/>
           </a:p>
         </p:txBody>
       </p:sp>
@@ -1478,7 +1482,7 @@
           <a:p>
             <a:pPr lvl="0"/>
             <a:r>
-              <a:rPr lang="en-US" smtClean="0"/>
+              <a:rPr lang="en-US"/>
               <a:t>Click to edit Master text styles</a:t>
             </a:r>
           </a:p>
@@ -1534,38 +1538,37 @@
           <a:p>
             <a:pPr lvl="0"/>
             <a:r>
-              <a:rPr lang="en-US" smtClean="0"/>
+              <a:rPr lang="en-US"/>
               <a:t>Click to edit Master text styles</a:t>
             </a:r>
           </a:p>
           <a:p>
             <a:pPr lvl="1"/>
             <a:r>
-              <a:rPr lang="en-US" smtClean="0"/>
+              <a:rPr lang="en-US"/>
               <a:t>Second level</a:t>
             </a:r>
           </a:p>
           <a:p>
             <a:pPr lvl="2"/>
             <a:r>
-              <a:rPr lang="en-US" smtClean="0"/>
+              <a:rPr lang="en-US"/>
               <a:t>Third level</a:t>
             </a:r>
           </a:p>
           <a:p>
             <a:pPr lvl="3"/>
             <a:r>
-              <a:rPr lang="en-US" smtClean="0"/>
+              <a:rPr lang="en-US"/>
               <a:t>Fourth level</a:t>
             </a:r>
           </a:p>
           <a:p>
             <a:pPr lvl="4"/>
             <a:r>
-              <a:rPr lang="en-US" smtClean="0"/>
+              <a:rPr lang="en-US"/>
               <a:t>Fifth level</a:t>
             </a:r>
-            <a:endParaRPr lang="en-US"/>
           </a:p>
         </p:txBody>
       </p:sp>
@@ -1628,7 +1631,7 @@
           <a:p>
             <a:pPr lvl="0"/>
             <a:r>
-              <a:rPr lang="en-US" smtClean="0"/>
+              <a:rPr lang="en-US"/>
               <a:t>Click to edit Master text styles</a:t>
             </a:r>
           </a:p>
@@ -1684,38 +1687,37 @@
           <a:p>
             <a:pPr lvl="0"/>
             <a:r>
-              <a:rPr lang="en-US" smtClean="0"/>
+              <a:rPr lang="en-US"/>
               <a:t>Click to edit Master text styles</a:t>
             </a:r>
           </a:p>
           <a:p>
             <a:pPr lvl="1"/>
             <a:r>
-              <a:rPr lang="en-US" smtClean="0"/>
+              <a:rPr lang="en-US"/>
               <a:t>Second level</a:t>
             </a:r>
           </a:p>
           <a:p>
             <a:pPr lvl="2"/>
             <a:r>
-              <a:rPr lang="en-US" smtClean="0"/>
+              <a:rPr lang="en-US"/>
               <a:t>Third level</a:t>
             </a:r>
           </a:p>
           <a:p>
             <a:pPr lvl="3"/>
             <a:r>
-              <a:rPr lang="en-US" smtClean="0"/>
+              <a:rPr lang="en-US"/>
               <a:t>Fourth level</a:t>
             </a:r>
           </a:p>
           <a:p>
             <a:pPr lvl="4"/>
             <a:r>
-              <a:rPr lang="en-US" smtClean="0"/>
+              <a:rPr lang="en-US"/>
               <a:t>Fifth level</a:t>
             </a:r>
-            <a:endParaRPr lang="en-US"/>
           </a:p>
         </p:txBody>
       </p:sp>
@@ -1736,7 +1738,7 @@
           <a:p>
             <a:fld id="{72CDDEA1-CAA3-44E9-BD20-01615CE14A03}" type="datetimeFigureOut">
               <a:rPr lang="en-US" smtClean="0"/>
-              <a:t>7/25/2022</a:t>
+              <a:t>8/3/2022</a:t>
             </a:fld>
             <a:endParaRPr lang="en-US"/>
           </a:p>
@@ -1825,10 +1827,9 @@
           <a:lstStyle/>
           <a:p>
             <a:r>
-              <a:rPr lang="en-US" smtClean="0"/>
+              <a:rPr lang="en-US"/>
               <a:t>Click to edit Master title style</a:t>
             </a:r>
-            <a:endParaRPr lang="en-US"/>
           </a:p>
         </p:txBody>
       </p:sp>
@@ -1849,7 +1850,7 @@
           <a:p>
             <a:fld id="{72CDDEA1-CAA3-44E9-BD20-01615CE14A03}" type="datetimeFigureOut">
               <a:rPr lang="en-US" smtClean="0"/>
-              <a:t>7/25/2022</a:t>
+              <a:t>8/3/2022</a:t>
             </a:fld>
             <a:endParaRPr lang="en-US"/>
           </a:p>
@@ -1939,7 +1940,7 @@
           <a:p>
             <a:fld id="{72CDDEA1-CAA3-44E9-BD20-01615CE14A03}" type="datetimeFigureOut">
               <a:rPr lang="en-US" smtClean="0"/>
-              <a:t>7/25/2022</a:t>
+              <a:t>8/3/2022</a:t>
             </a:fld>
             <a:endParaRPr lang="en-US"/>
           </a:p>
@@ -2037,10 +2038,9 @@
           </a:lstStyle>
           <a:p>
             <a:r>
-              <a:rPr lang="en-US" smtClean="0"/>
+              <a:rPr lang="en-US"/>
               <a:t>Click to edit Master title style</a:t>
             </a:r>
-            <a:endParaRPr lang="en-US"/>
           </a:p>
         </p:txBody>
       </p:sp>
@@ -2094,38 +2094,37 @@
           <a:p>
             <a:pPr lvl="0"/>
             <a:r>
-              <a:rPr lang="en-US" smtClean="0"/>
+              <a:rPr lang="en-US"/>
               <a:t>Click to edit Master text styles</a:t>
             </a:r>
           </a:p>
           <a:p>
             <a:pPr lvl="1"/>
             <a:r>
-              <a:rPr lang="en-US" smtClean="0"/>
+              <a:rPr lang="en-US"/>
               <a:t>Second level</a:t>
             </a:r>
           </a:p>
           <a:p>
             <a:pPr lvl="2"/>
             <a:r>
-              <a:rPr lang="en-US" smtClean="0"/>
+              <a:rPr lang="en-US"/>
               <a:t>Third level</a:t>
             </a:r>
           </a:p>
           <a:p>
             <a:pPr lvl="3"/>
             <a:r>
-              <a:rPr lang="en-US" smtClean="0"/>
+              <a:rPr lang="en-US"/>
               <a:t>Fourth level</a:t>
             </a:r>
           </a:p>
           <a:p>
             <a:pPr lvl="4"/>
             <a:r>
-              <a:rPr lang="en-US" smtClean="0"/>
+              <a:rPr lang="en-US"/>
               <a:t>Fifth level</a:t>
             </a:r>
-            <a:endParaRPr lang="en-US"/>
           </a:p>
         </p:txBody>
       </p:sp>
@@ -2188,7 +2187,7 @@
           <a:p>
             <a:pPr lvl="0"/>
             <a:r>
-              <a:rPr lang="en-US" smtClean="0"/>
+              <a:rPr lang="en-US"/>
               <a:t>Click to edit Master text styles</a:t>
             </a:r>
           </a:p>
@@ -2211,7 +2210,7 @@
           <a:p>
             <a:fld id="{72CDDEA1-CAA3-44E9-BD20-01615CE14A03}" type="datetimeFigureOut">
               <a:rPr lang="en-US" smtClean="0"/>
-              <a:t>7/25/2022</a:t>
+              <a:t>8/3/2022</a:t>
             </a:fld>
             <a:endParaRPr lang="en-US"/>
           </a:p>
@@ -2309,10 +2308,9 @@
           </a:lstStyle>
           <a:p>
             <a:r>
-              <a:rPr lang="en-US" smtClean="0"/>
+              <a:rPr lang="en-US"/>
               <a:t>Click to edit Master title style</a:t>
             </a:r>
-            <a:endParaRPr lang="en-US"/>
           </a:p>
         </p:txBody>
       </p:sp>
@@ -2436,7 +2434,7 @@
           <a:p>
             <a:pPr lvl="0"/>
             <a:r>
-              <a:rPr lang="en-US" smtClean="0"/>
+              <a:rPr lang="en-US"/>
               <a:t>Click to edit Master text styles</a:t>
             </a:r>
           </a:p>
@@ -2459,7 +2457,7 @@
           <a:p>
             <a:fld id="{72CDDEA1-CAA3-44E9-BD20-01615CE14A03}" type="datetimeFigureOut">
               <a:rPr lang="en-US" smtClean="0"/>
-              <a:t>7/25/2022</a:t>
+              <a:t>8/3/2022</a:t>
             </a:fld>
             <a:endParaRPr lang="en-US"/>
           </a:p>
@@ -2563,10 +2561,9 @@
           <a:lstStyle/>
           <a:p>
             <a:r>
-              <a:rPr lang="en-US" smtClean="0"/>
+              <a:rPr lang="en-US"/>
               <a:t>Click to edit Master title style</a:t>
             </a:r>
-            <a:endParaRPr lang="en-US"/>
           </a:p>
         </p:txBody>
       </p:sp>
@@ -2597,38 +2594,37 @@
           <a:p>
             <a:pPr lvl="0"/>
             <a:r>
-              <a:rPr lang="en-US" smtClean="0"/>
+              <a:rPr lang="en-US"/>
               <a:t>Click to edit Master text styles</a:t>
             </a:r>
           </a:p>
           <a:p>
             <a:pPr lvl="1"/>
             <a:r>
-              <a:rPr lang="en-US" smtClean="0"/>
+              <a:rPr lang="en-US"/>
               <a:t>Second level</a:t>
             </a:r>
           </a:p>
           <a:p>
             <a:pPr lvl="2"/>
             <a:r>
-              <a:rPr lang="en-US" smtClean="0"/>
+              <a:rPr lang="en-US"/>
               <a:t>Third level</a:t>
             </a:r>
           </a:p>
           <a:p>
             <a:pPr lvl="3"/>
             <a:r>
-              <a:rPr lang="en-US" smtClean="0"/>
+              <a:rPr lang="en-US"/>
               <a:t>Fourth level</a:t>
             </a:r>
           </a:p>
           <a:p>
             <a:pPr lvl="4"/>
             <a:r>
-              <a:rPr lang="en-US" smtClean="0"/>
+              <a:rPr lang="en-US"/>
               <a:t>Fifth level</a:t>
             </a:r>
-            <a:endParaRPr lang="en-US"/>
           </a:p>
         </p:txBody>
       </p:sp>
@@ -2667,7 +2663,7 @@
           <a:p>
             <a:fld id="{72CDDEA1-CAA3-44E9-BD20-01615CE14A03}" type="datetimeFigureOut">
               <a:rPr lang="en-US" smtClean="0"/>
-              <a:t>7/25/2022</a:t>
+              <a:t>8/3/2022</a:t>
             </a:fld>
             <a:endParaRPr lang="en-US"/>
           </a:p>
@@ -3707,7 +3703,1133 @@
           <a:chExt cx="0" cy="0"/>
         </a:xfrm>
       </p:grpSpPr>
+      <p:pic>
+        <p:nvPicPr>
+          <p:cNvPr id="27" name="Picture 26" descr="10-109406_button-media-player-icon-icon-play-pause-stop.png">
+            <a:extLst>
+              <a:ext uri="{FF2B5EF4-FFF2-40B4-BE49-F238E27FC236}">
+                <a16:creationId xmlns:a16="http://schemas.microsoft.com/office/drawing/2014/main" id="{0E49D43C-C30B-8C2C-1E32-665562DC7773}"/>
+              </a:ext>
+            </a:extLst>
+          </p:cNvPr>
+          <p:cNvPicPr>
+            <a:picLocks noChangeAspect="1"/>
+          </p:cNvPicPr>
+          <p:nvPr/>
+        </p:nvPicPr>
+        <p:blipFill>
+          <a:blip r:embed="rId2" cstate="print">
+            <a:duotone>
+              <a:schemeClr val="accent6">
+                <a:shade val="45000"/>
+                <a:satMod val="135000"/>
+              </a:schemeClr>
+              <a:prstClr val="white"/>
+            </a:duotone>
+          </a:blip>
+          <a:srcRect l="28024" t="6301" r="51758" b="68572"/>
+          <a:stretch>
+            <a:fillRect/>
+          </a:stretch>
+        </p:blipFill>
+        <p:spPr>
+          <a:xfrm>
+            <a:off x="251520" y="332656"/>
+            <a:ext cx="1656184" cy="1656184"/>
+          </a:xfrm>
+          <a:prstGeom prst="rect">
+            <a:avLst/>
+          </a:prstGeom>
+        </p:spPr>
+      </p:pic>
+      <p:pic>
+        <p:nvPicPr>
+          <p:cNvPr id="28" name="Picture 27" descr="10-109406_button-media-player-icon-icon-play-pause-stop.png">
+            <a:extLst>
+              <a:ext uri="{FF2B5EF4-FFF2-40B4-BE49-F238E27FC236}">
+                <a16:creationId xmlns:a16="http://schemas.microsoft.com/office/drawing/2014/main" id="{ECB6A31C-957C-4F2E-C7E9-BD7A8FABBEC5}"/>
+              </a:ext>
+            </a:extLst>
+          </p:cNvPr>
+          <p:cNvPicPr>
+            <a:picLocks noChangeAspect="1"/>
+          </p:cNvPicPr>
+          <p:nvPr/>
+        </p:nvPicPr>
+        <p:blipFill>
+          <a:blip r:embed="rId2" cstate="print">
+            <a:duotone>
+              <a:schemeClr val="accent6">
+                <a:shade val="45000"/>
+                <a:satMod val="135000"/>
+              </a:schemeClr>
+              <a:prstClr val="white"/>
+            </a:duotone>
+          </a:blip>
+          <a:srcRect l="51758" t="6301" r="28024" b="68572"/>
+          <a:stretch>
+            <a:fillRect/>
+          </a:stretch>
+        </p:blipFill>
+        <p:spPr>
+          <a:xfrm>
+            <a:off x="2267744" y="332656"/>
+            <a:ext cx="1656184" cy="1656184"/>
+          </a:xfrm>
+          <a:prstGeom prst="rect">
+            <a:avLst/>
+          </a:prstGeom>
+        </p:spPr>
+      </p:pic>
+      <p:pic>
+        <p:nvPicPr>
+          <p:cNvPr id="29" name="Picture 28" descr="10-109406_button-media-player-icon-icon-play-pause-stop.png">
+            <a:extLst>
+              <a:ext uri="{FF2B5EF4-FFF2-40B4-BE49-F238E27FC236}">
+                <a16:creationId xmlns:a16="http://schemas.microsoft.com/office/drawing/2014/main" id="{97B220E7-1F3E-47DE-7502-285E9D6A6C83}"/>
+              </a:ext>
+            </a:extLst>
+          </p:cNvPr>
+          <p:cNvPicPr>
+            <a:picLocks noChangeAspect="1"/>
+          </p:cNvPicPr>
+          <p:nvPr/>
+        </p:nvPicPr>
+        <p:blipFill>
+          <a:blip r:embed="rId2" cstate="print">
+            <a:duotone>
+              <a:schemeClr val="accent6">
+                <a:shade val="45000"/>
+                <a:satMod val="135000"/>
+              </a:schemeClr>
+              <a:prstClr val="white"/>
+            </a:duotone>
+          </a:blip>
+          <a:srcRect l="75599" t="6463" r="4183" b="68410"/>
+          <a:stretch>
+            <a:fillRect/>
+          </a:stretch>
+        </p:blipFill>
+        <p:spPr>
+          <a:xfrm>
+            <a:off x="4067944" y="404664"/>
+            <a:ext cx="1656184" cy="1656184"/>
+          </a:xfrm>
+          <a:prstGeom prst="rect">
+            <a:avLst/>
+          </a:prstGeom>
+        </p:spPr>
+      </p:pic>
+      <p:pic>
+        <p:nvPicPr>
+          <p:cNvPr id="30" name="Picture 29" descr="10-109406_button-media-player-icon-icon-play-pause-stop.png">
+            <a:extLst>
+              <a:ext uri="{FF2B5EF4-FFF2-40B4-BE49-F238E27FC236}">
+                <a16:creationId xmlns:a16="http://schemas.microsoft.com/office/drawing/2014/main" id="{B850DA49-0A86-2D71-3388-7455A6B6C558}"/>
+              </a:ext>
+            </a:extLst>
+          </p:cNvPr>
+          <p:cNvPicPr>
+            <a:picLocks noChangeAspect="1"/>
+          </p:cNvPicPr>
+          <p:nvPr/>
+        </p:nvPicPr>
+        <p:blipFill>
+          <a:blip r:embed="rId2" cstate="print">
+            <a:duotone>
+              <a:schemeClr val="accent6">
+                <a:shade val="45000"/>
+                <a:satMod val="135000"/>
+              </a:schemeClr>
+              <a:prstClr val="white"/>
+            </a:duotone>
+          </a:blip>
+          <a:srcRect l="28024" t="37983" r="51758" b="36890"/>
+          <a:stretch>
+            <a:fillRect/>
+          </a:stretch>
+        </p:blipFill>
+        <p:spPr>
+          <a:xfrm>
+            <a:off x="2771800" y="2636912"/>
+            <a:ext cx="1656184" cy="1656184"/>
+          </a:xfrm>
+          <a:prstGeom prst="rect">
+            <a:avLst/>
+          </a:prstGeom>
+        </p:spPr>
+      </p:pic>
+      <p:pic>
+        <p:nvPicPr>
+          <p:cNvPr id="31" name="Picture 30" descr="10-109406_button-media-player-icon-icon-play-pause-stop.png">
+            <a:extLst>
+              <a:ext uri="{FF2B5EF4-FFF2-40B4-BE49-F238E27FC236}">
+                <a16:creationId xmlns:a16="http://schemas.microsoft.com/office/drawing/2014/main" id="{586B06CE-2576-BD07-3DA2-0B8C71235F0D}"/>
+              </a:ext>
+            </a:extLst>
+          </p:cNvPr>
+          <p:cNvPicPr>
+            <a:picLocks noChangeAspect="1"/>
+          </p:cNvPicPr>
+          <p:nvPr/>
+        </p:nvPicPr>
+        <p:blipFill>
+          <a:blip r:embed="rId2" cstate="print">
+            <a:duotone>
+              <a:schemeClr val="accent6">
+                <a:shade val="45000"/>
+                <a:satMod val="135000"/>
+              </a:schemeClr>
+              <a:prstClr val="white"/>
+            </a:duotone>
+          </a:blip>
+          <a:srcRect l="51758" t="37983" r="28024" b="36890"/>
+          <a:stretch>
+            <a:fillRect/>
+          </a:stretch>
+        </p:blipFill>
+        <p:spPr>
+          <a:xfrm>
+            <a:off x="4716016" y="2636912"/>
+            <a:ext cx="1656184" cy="1656184"/>
+          </a:xfrm>
+          <a:prstGeom prst="rect">
+            <a:avLst/>
+          </a:prstGeom>
+        </p:spPr>
+      </p:pic>
+      <p:pic>
+        <p:nvPicPr>
+          <p:cNvPr id="32" name="Picture 31" descr="10-109406_button-media-player-icon-icon-play-pause-stop.png">
+            <a:extLst>
+              <a:ext uri="{FF2B5EF4-FFF2-40B4-BE49-F238E27FC236}">
+                <a16:creationId xmlns:a16="http://schemas.microsoft.com/office/drawing/2014/main" id="{384C8230-70FD-56FA-C4B1-203EA107058E}"/>
+              </a:ext>
+            </a:extLst>
+          </p:cNvPr>
+          <p:cNvPicPr>
+            <a:picLocks noChangeAspect="1"/>
+          </p:cNvPicPr>
+          <p:nvPr/>
+        </p:nvPicPr>
+        <p:blipFill>
+          <a:blip r:embed="rId2" cstate="print">
+            <a:duotone>
+              <a:schemeClr val="accent6">
+                <a:shade val="45000"/>
+                <a:satMod val="135000"/>
+              </a:schemeClr>
+              <a:prstClr val="white"/>
+            </a:duotone>
+          </a:blip>
+          <a:srcRect l="75493" t="67480" r="3410" b="6301"/>
+          <a:stretch>
+            <a:fillRect/>
+          </a:stretch>
+        </p:blipFill>
+        <p:spPr>
+          <a:xfrm>
+            <a:off x="6300192" y="260648"/>
+            <a:ext cx="1728192" cy="1728192"/>
+          </a:xfrm>
+          <a:prstGeom prst="rect">
+            <a:avLst/>
+          </a:prstGeom>
+        </p:spPr>
+      </p:pic>
+      <p:grpSp>
+        <p:nvGrpSpPr>
+          <p:cNvPr id="33" name="Group 32">
+            <a:extLst>
+              <a:ext uri="{FF2B5EF4-FFF2-40B4-BE49-F238E27FC236}">
+                <a16:creationId xmlns:a16="http://schemas.microsoft.com/office/drawing/2014/main" id="{971176AF-143B-A2E0-8640-9979BE660042}"/>
+              </a:ext>
+            </a:extLst>
+          </p:cNvPr>
+          <p:cNvGrpSpPr/>
+          <p:nvPr/>
+        </p:nvGrpSpPr>
+        <p:grpSpPr>
+          <a:xfrm>
+            <a:off x="467544" y="2564904"/>
+            <a:ext cx="1728192" cy="1656184"/>
+            <a:chOff x="755576" y="548680"/>
+            <a:chExt cx="1728192" cy="1656184"/>
+          </a:xfrm>
+        </p:grpSpPr>
+        <p:pic>
+          <p:nvPicPr>
+            <p:cNvPr id="34" name="Picture 33" descr="10-109406_button-media-player-icon-icon-play-pause-stop.png">
+              <a:extLst>
+                <a:ext uri="{FF2B5EF4-FFF2-40B4-BE49-F238E27FC236}">
+                  <a16:creationId xmlns:a16="http://schemas.microsoft.com/office/drawing/2014/main" id="{8B3428B0-D70B-FF82-2DF2-777DDAE9628F}"/>
+                </a:ext>
+              </a:extLst>
+            </p:cNvPr>
+            <p:cNvPicPr>
+              <a:picLocks noChangeAspect="1"/>
+            </p:cNvPicPr>
+            <p:nvPr/>
+          </p:nvPicPr>
+          <p:blipFill>
+            <a:blip r:embed="rId2" cstate="print">
+              <a:duotone>
+                <a:schemeClr val="accent6">
+                  <a:shade val="45000"/>
+                  <a:satMod val="135000"/>
+                </a:schemeClr>
+                <a:prstClr val="white"/>
+              </a:duotone>
+            </a:blip>
+            <a:srcRect l="3410" t="6301" r="75493" b="68572"/>
+            <a:stretch>
+              <a:fillRect/>
+            </a:stretch>
+          </p:blipFill>
+          <p:spPr>
+            <a:xfrm>
+              <a:off x="755576" y="548680"/>
+              <a:ext cx="1728192" cy="1656184"/>
+            </a:xfrm>
+            <a:prstGeom prst="rect">
+              <a:avLst/>
+            </a:prstGeom>
+          </p:spPr>
+        </p:pic>
+        <p:grpSp>
+          <p:nvGrpSpPr>
+            <p:cNvPr id="35" name="Group 25">
+              <a:extLst>
+                <a:ext uri="{FF2B5EF4-FFF2-40B4-BE49-F238E27FC236}">
+                  <a16:creationId xmlns:a16="http://schemas.microsoft.com/office/drawing/2014/main" id="{6E49F301-969F-6519-775D-0583F3A152D7}"/>
+                </a:ext>
+              </a:extLst>
+            </p:cNvPr>
+            <p:cNvGrpSpPr/>
+            <p:nvPr/>
+          </p:nvGrpSpPr>
+          <p:grpSpPr>
+            <a:xfrm>
+              <a:off x="971600" y="836712"/>
+              <a:ext cx="1296144" cy="1008112"/>
+              <a:chOff x="4337587" y="879358"/>
+              <a:chExt cx="1533452" cy="1245236"/>
+            </a:xfrm>
+          </p:grpSpPr>
+          <p:grpSp>
+            <p:nvGrpSpPr>
+              <p:cNvPr id="36" name="Group 17">
+                <a:extLst>
+                  <a:ext uri="{FF2B5EF4-FFF2-40B4-BE49-F238E27FC236}">
+                    <a16:creationId xmlns:a16="http://schemas.microsoft.com/office/drawing/2014/main" id="{1CE4845A-30EC-96C8-F88D-C6DE39812AD9}"/>
+                  </a:ext>
+                </a:extLst>
+              </p:cNvPr>
+              <p:cNvGrpSpPr/>
+              <p:nvPr/>
+            </p:nvGrpSpPr>
+            <p:grpSpPr>
+              <a:xfrm>
+                <a:off x="4337587" y="879358"/>
+                <a:ext cx="1533452" cy="1245236"/>
+                <a:chOff x="4337587" y="879358"/>
+                <a:chExt cx="1533452" cy="1245236"/>
+              </a:xfrm>
+            </p:grpSpPr>
+            <p:grpSp>
+              <p:nvGrpSpPr>
+                <p:cNvPr id="41" name="Group 14">
+                  <a:extLst>
+                    <a:ext uri="{FF2B5EF4-FFF2-40B4-BE49-F238E27FC236}">
+                      <a16:creationId xmlns:a16="http://schemas.microsoft.com/office/drawing/2014/main" id="{68DDFBB1-D56E-68D0-55DC-108924DDFC0A}"/>
+                    </a:ext>
+                  </a:extLst>
+                </p:cNvPr>
+                <p:cNvGrpSpPr/>
+                <p:nvPr/>
+              </p:nvGrpSpPr>
+              <p:grpSpPr>
+                <a:xfrm rot="2791999">
+                  <a:off x="4682907" y="771346"/>
+                  <a:ext cx="1080120" cy="1296144"/>
+                  <a:chOff x="4499992" y="692696"/>
+                  <a:chExt cx="1080120" cy="1296144"/>
+                </a:xfrm>
+              </p:grpSpPr>
+              <p:pic>
+                <p:nvPicPr>
+                  <p:cNvPr id="43" name="Picture 9" descr="10-109406_button-media-player-icon-icon-play-pause-stop.png">
+                    <a:extLst>
+                      <a:ext uri="{FF2B5EF4-FFF2-40B4-BE49-F238E27FC236}">
+                        <a16:creationId xmlns:a16="http://schemas.microsoft.com/office/drawing/2014/main" id="{0C4EC293-3249-0DB0-4944-412162C0303F}"/>
+                      </a:ext>
+                    </a:extLst>
+                  </p:cNvPr>
+                  <p:cNvPicPr>
+                    <a:picLocks noChangeAspect="1"/>
+                  </p:cNvPicPr>
+                  <p:nvPr/>
+                </p:nvPicPr>
+                <p:blipFill>
+                  <a:blip r:embed="rId2" cstate="print">
+                    <a:duotone>
+                      <a:schemeClr val="accent6">
+                        <a:shade val="45000"/>
+                        <a:satMod val="135000"/>
+                      </a:schemeClr>
+                      <a:prstClr val="white"/>
+                    </a:duotone>
+                  </a:blip>
+                  <a:srcRect l="7805" t="10671" r="79888" b="72942"/>
+                  <a:stretch>
+                    <a:fillRect/>
+                  </a:stretch>
+                </p:blipFill>
+                <p:spPr>
+                  <a:xfrm>
+                    <a:off x="4572000" y="908720"/>
+                    <a:ext cx="1008112" cy="1080120"/>
+                  </a:xfrm>
+                  <a:prstGeom prst="rect">
+                    <a:avLst/>
+                  </a:prstGeom>
+                </p:spPr>
+              </p:pic>
+              <p:pic>
+                <p:nvPicPr>
+                  <p:cNvPr id="44" name="Picture 43" descr="10-109406_button-media-player-icon-icon-play-pause-stop.png">
+                    <a:extLst>
+                      <a:ext uri="{FF2B5EF4-FFF2-40B4-BE49-F238E27FC236}">
+                        <a16:creationId xmlns:a16="http://schemas.microsoft.com/office/drawing/2014/main" id="{654BD155-0394-B0EA-BDC5-D6A1322B8DD5}"/>
+                      </a:ext>
+                    </a:extLst>
+                  </p:cNvPr>
+                  <p:cNvPicPr>
+                    <a:picLocks noChangeAspect="1"/>
+                  </p:cNvPicPr>
+                  <p:nvPr/>
+                </p:nvPicPr>
+                <p:blipFill>
+                  <a:blip r:embed="rId2" cstate="print">
+                    <a:duotone>
+                      <a:schemeClr val="accent6">
+                        <a:shade val="45000"/>
+                        <a:satMod val="135000"/>
+                      </a:schemeClr>
+                      <a:prstClr val="white"/>
+                    </a:duotone>
+                  </a:blip>
+                  <a:srcRect l="16596" t="10671" r="79888" b="72942"/>
+                  <a:stretch>
+                    <a:fillRect/>
+                  </a:stretch>
+                </p:blipFill>
+                <p:spPr>
+                  <a:xfrm rot="16200000">
+                    <a:off x="4896036" y="584684"/>
+                    <a:ext cx="288032" cy="1080120"/>
+                  </a:xfrm>
+                  <a:prstGeom prst="rect">
+                    <a:avLst/>
+                  </a:prstGeom>
+                </p:spPr>
+              </p:pic>
+              <p:sp>
+                <p:nvSpPr>
+                  <p:cNvPr id="45" name="Rectangle 44">
+                    <a:extLst>
+                      <a:ext uri="{FF2B5EF4-FFF2-40B4-BE49-F238E27FC236}">
+                        <a16:creationId xmlns:a16="http://schemas.microsoft.com/office/drawing/2014/main" id="{70C1132A-2E55-D313-C33D-21B3FB166122}"/>
+                      </a:ext>
+                    </a:extLst>
+                  </p:cNvPr>
+                  <p:cNvSpPr/>
+                  <p:nvPr/>
+                </p:nvSpPr>
+                <p:spPr>
+                  <a:xfrm>
+                    <a:off x="4932040" y="1268760"/>
+                    <a:ext cx="288032" cy="288032"/>
+                  </a:xfrm>
+                  <a:prstGeom prst="rect">
+                    <a:avLst/>
+                  </a:prstGeom>
+                  <a:solidFill>
+                    <a:schemeClr val="bg1"/>
+                  </a:solidFill>
+                  <a:ln>
+                    <a:solidFill>
+                      <a:schemeClr val="bg1"/>
+                    </a:solidFill>
+                  </a:ln>
+                </p:spPr>
+                <p:style>
+                  <a:lnRef idx="2">
+                    <a:schemeClr val="accent1">
+                      <a:shade val="50000"/>
+                    </a:schemeClr>
+                  </a:lnRef>
+                  <a:fillRef idx="1">
+                    <a:schemeClr val="accent1"/>
+                  </a:fillRef>
+                  <a:effectRef idx="0">
+                    <a:schemeClr val="accent1"/>
+                  </a:effectRef>
+                  <a:fontRef idx="minor">
+                    <a:schemeClr val="lt1"/>
+                  </a:fontRef>
+                </p:style>
+                <p:txBody>
+                  <a:bodyPr rtlCol="0" anchor="ctr"/>
+                  <a:lstStyle/>
+                  <a:p>
+                    <a:pPr algn="ctr"/>
+                    <a:endParaRPr lang="en-US"/>
+                  </a:p>
+                </p:txBody>
+              </p:sp>
+              <p:sp>
+                <p:nvSpPr>
+                  <p:cNvPr id="46" name="Rectangle 45">
+                    <a:extLst>
+                      <a:ext uri="{FF2B5EF4-FFF2-40B4-BE49-F238E27FC236}">
+                        <a16:creationId xmlns:a16="http://schemas.microsoft.com/office/drawing/2014/main" id="{C85F3DBE-C5F8-4AE9-4A0B-8D78F3869313}"/>
+                      </a:ext>
+                    </a:extLst>
+                  </p:cNvPr>
+                  <p:cNvSpPr/>
+                  <p:nvPr/>
+                </p:nvSpPr>
+                <p:spPr>
+                  <a:xfrm>
+                    <a:off x="4932040" y="692696"/>
+                    <a:ext cx="360040" cy="360040"/>
+                  </a:xfrm>
+                  <a:prstGeom prst="rect">
+                    <a:avLst/>
+                  </a:prstGeom>
+                  <a:solidFill>
+                    <a:schemeClr val="bg1"/>
+                  </a:solidFill>
+                  <a:ln>
+                    <a:solidFill>
+                      <a:schemeClr val="bg1"/>
+                    </a:solidFill>
+                  </a:ln>
+                </p:spPr>
+                <p:style>
+                  <a:lnRef idx="2">
+                    <a:schemeClr val="accent1">
+                      <a:shade val="50000"/>
+                    </a:schemeClr>
+                  </a:lnRef>
+                  <a:fillRef idx="1">
+                    <a:schemeClr val="accent1"/>
+                  </a:fillRef>
+                  <a:effectRef idx="0">
+                    <a:schemeClr val="accent1"/>
+                  </a:effectRef>
+                  <a:fontRef idx="minor">
+                    <a:schemeClr val="lt1"/>
+                  </a:fontRef>
+                </p:style>
+                <p:txBody>
+                  <a:bodyPr rtlCol="0" anchor="ctr"/>
+                  <a:lstStyle/>
+                  <a:p>
+                    <a:pPr algn="ctr"/>
+                    <a:endParaRPr lang="en-US"/>
+                  </a:p>
+                </p:txBody>
+              </p:sp>
+            </p:grpSp>
+            <p:pic>
+              <p:nvPicPr>
+                <p:cNvPr id="42" name="Picture 41" descr="10-109406_button-media-player-icon-icon-play-pause-stop.png">
+                  <a:extLst>
+                    <a:ext uri="{FF2B5EF4-FFF2-40B4-BE49-F238E27FC236}">
+                      <a16:creationId xmlns:a16="http://schemas.microsoft.com/office/drawing/2014/main" id="{05412451-7F6D-4C8C-7597-B0A71D9D9422}"/>
+                    </a:ext>
+                  </a:extLst>
+                </p:cNvPr>
+                <p:cNvPicPr>
+                  <a:picLocks noChangeAspect="1"/>
+                </p:cNvPicPr>
+                <p:nvPr/>
+              </p:nvPicPr>
+              <p:blipFill>
+                <a:blip r:embed="rId2" cstate="print">
+                  <a:duotone>
+                    <a:schemeClr val="accent6">
+                      <a:shade val="45000"/>
+                      <a:satMod val="135000"/>
+                    </a:schemeClr>
+                    <a:prstClr val="white"/>
+                  </a:duotone>
+                </a:blip>
+                <a:srcRect l="13079" t="10671" r="84284" b="78404"/>
+                <a:stretch>
+                  <a:fillRect/>
+                </a:stretch>
+              </p:blipFill>
+              <p:spPr>
+                <a:xfrm rot="2791999">
+                  <a:off x="4589615" y="1656542"/>
+                  <a:ext cx="216024" cy="720080"/>
+                </a:xfrm>
+                <a:prstGeom prst="rect">
+                  <a:avLst/>
+                </a:prstGeom>
+              </p:spPr>
+            </p:pic>
+          </p:grpSp>
+          <p:pic>
+            <p:nvPicPr>
+              <p:cNvPr id="37" name="Picture 36" descr="10-109406_button-media-player-icon-icon-play-pause-stop.png">
+                <a:extLst>
+                  <a:ext uri="{FF2B5EF4-FFF2-40B4-BE49-F238E27FC236}">
+                    <a16:creationId xmlns:a16="http://schemas.microsoft.com/office/drawing/2014/main" id="{128730B2-BF95-0F20-D2F4-9BF0DDE02763}"/>
+                  </a:ext>
+                </a:extLst>
+              </p:cNvPr>
+              <p:cNvPicPr>
+                <a:picLocks noChangeAspect="1"/>
+              </p:cNvPicPr>
+              <p:nvPr/>
+            </p:nvPicPr>
+            <p:blipFill>
+              <a:blip r:embed="rId2" cstate="print">
+                <a:duotone>
+                  <a:schemeClr val="accent6">
+                    <a:shade val="45000"/>
+                    <a:satMod val="135000"/>
+                  </a:schemeClr>
+                  <a:prstClr val="white"/>
+                </a:duotone>
+              </a:blip>
+              <a:srcRect l="13933" t="11393" r="85188" b="80960"/>
+              <a:stretch>
+                <a:fillRect/>
+              </a:stretch>
+            </p:blipFill>
+            <p:spPr>
+              <a:xfrm rot="7920000">
+                <a:off x="4949030" y="1584309"/>
+                <a:ext cx="56572" cy="396000"/>
+              </a:xfrm>
+              <a:prstGeom prst="rect">
+                <a:avLst/>
+              </a:prstGeom>
+            </p:spPr>
+          </p:pic>
+          <p:pic>
+            <p:nvPicPr>
+              <p:cNvPr id="38" name="Picture 37" descr="10-109406_button-media-player-icon-icon-play-pause-stop.png">
+                <a:extLst>
+                  <a:ext uri="{FF2B5EF4-FFF2-40B4-BE49-F238E27FC236}">
+                    <a16:creationId xmlns:a16="http://schemas.microsoft.com/office/drawing/2014/main" id="{FB5AE40D-6710-F1A3-65E9-05C0E17C4C22}"/>
+                  </a:ext>
+                </a:extLst>
+              </p:cNvPr>
+              <p:cNvPicPr>
+                <a:picLocks noChangeAspect="1"/>
+              </p:cNvPicPr>
+              <p:nvPr/>
+            </p:nvPicPr>
+            <p:blipFill>
+              <a:blip r:embed="rId2" cstate="print">
+                <a:duotone>
+                  <a:schemeClr val="accent6">
+                    <a:shade val="45000"/>
+                    <a:satMod val="135000"/>
+                  </a:schemeClr>
+                  <a:prstClr val="white"/>
+                </a:duotone>
+              </a:blip>
+              <a:srcRect l="13933" t="11393" r="85188" b="80960"/>
+              <a:stretch>
+                <a:fillRect/>
+              </a:stretch>
+            </p:blipFill>
+            <p:spPr>
+              <a:xfrm rot="7920000">
+                <a:off x="4925808" y="1637331"/>
+                <a:ext cx="56572" cy="396000"/>
+              </a:xfrm>
+              <a:prstGeom prst="rect">
+                <a:avLst/>
+              </a:prstGeom>
+            </p:spPr>
+          </p:pic>
+          <p:pic>
+            <p:nvPicPr>
+              <p:cNvPr id="39" name="Picture 38" descr="10-109406_button-media-player-icon-icon-play-pause-stop.png">
+                <a:extLst>
+                  <a:ext uri="{FF2B5EF4-FFF2-40B4-BE49-F238E27FC236}">
+                    <a16:creationId xmlns:a16="http://schemas.microsoft.com/office/drawing/2014/main" id="{E25A2B4C-FAA3-FE90-1B57-D136513C09DB}"/>
+                  </a:ext>
+                </a:extLst>
+              </p:cNvPr>
+              <p:cNvPicPr>
+                <a:picLocks noChangeAspect="1"/>
+              </p:cNvPicPr>
+              <p:nvPr/>
+            </p:nvPicPr>
+            <p:blipFill>
+              <a:blip r:embed="rId2" cstate="print">
+                <a:duotone>
+                  <a:schemeClr val="accent6">
+                    <a:shade val="45000"/>
+                    <a:satMod val="135000"/>
+                  </a:schemeClr>
+                  <a:prstClr val="white"/>
+                </a:duotone>
+              </a:blip>
+              <a:srcRect l="13933" t="11393" r="85188" b="80960"/>
+              <a:stretch>
+                <a:fillRect/>
+              </a:stretch>
+            </p:blipFill>
+            <p:spPr>
+              <a:xfrm rot="7920000">
+                <a:off x="4953708" y="1584309"/>
+                <a:ext cx="56572" cy="396000"/>
+              </a:xfrm>
+              <a:prstGeom prst="rect">
+                <a:avLst/>
+              </a:prstGeom>
+            </p:spPr>
+          </p:pic>
+          <p:pic>
+            <p:nvPicPr>
+              <p:cNvPr id="40" name="Picture 39" descr="10-109406_button-media-player-icon-icon-play-pause-stop.png">
+                <a:extLst>
+                  <a:ext uri="{FF2B5EF4-FFF2-40B4-BE49-F238E27FC236}">
+                    <a16:creationId xmlns:a16="http://schemas.microsoft.com/office/drawing/2014/main" id="{D4AB7F52-A024-5A20-8A5B-B0D6C6452F44}"/>
+                  </a:ext>
+                </a:extLst>
+              </p:cNvPr>
+              <p:cNvPicPr>
+                <a:picLocks noChangeAspect="1"/>
+              </p:cNvPicPr>
+              <p:nvPr/>
+            </p:nvPicPr>
+            <p:blipFill>
+              <a:blip r:embed="rId2" cstate="print">
+                <a:duotone>
+                  <a:schemeClr val="accent6">
+                    <a:shade val="45000"/>
+                    <a:satMod val="135000"/>
+                  </a:schemeClr>
+                  <a:prstClr val="white"/>
+                </a:duotone>
+              </a:blip>
+              <a:srcRect l="13933" t="11393" r="85188" b="80960"/>
+              <a:stretch>
+                <a:fillRect/>
+              </a:stretch>
+            </p:blipFill>
+            <p:spPr>
+              <a:xfrm rot="15120000">
+                <a:off x="5148000" y="1692000"/>
+                <a:ext cx="56572" cy="396000"/>
+              </a:xfrm>
+              <a:prstGeom prst="rect">
+                <a:avLst/>
+              </a:prstGeom>
+            </p:spPr>
+          </p:pic>
+        </p:grpSp>
+      </p:grpSp>
+      <p:pic>
+        <p:nvPicPr>
+          <p:cNvPr id="47" name="Picture 46" descr="10-109406_button-media-player-icon-icon-play-pause-stop.png">
+            <a:extLst>
+              <a:ext uri="{FF2B5EF4-FFF2-40B4-BE49-F238E27FC236}">
+                <a16:creationId xmlns:a16="http://schemas.microsoft.com/office/drawing/2014/main" id="{BA2497E0-619A-E2DD-E1FE-77F496DFF6B4}"/>
+              </a:ext>
+            </a:extLst>
+          </p:cNvPr>
+          <p:cNvPicPr>
+            <a:picLocks noChangeAspect="1"/>
+          </p:cNvPicPr>
+          <p:nvPr/>
+        </p:nvPicPr>
+        <p:blipFill>
+          <a:blip r:embed="rId2" cstate="print">
+            <a:duotone>
+              <a:schemeClr val="accent6">
+                <a:shade val="45000"/>
+                <a:satMod val="135000"/>
+              </a:schemeClr>
+              <a:prstClr val="white"/>
+            </a:duotone>
+          </a:blip>
+          <a:srcRect l="28024" t="6301" r="51758" b="68572"/>
+          <a:stretch>
+            <a:fillRect/>
+          </a:stretch>
+        </p:blipFill>
+        <p:spPr>
+          <a:xfrm flipH="1">
+            <a:off x="539552" y="4581128"/>
+            <a:ext cx="1656184" cy="1656184"/>
+          </a:xfrm>
+          <a:prstGeom prst="rect">
+            <a:avLst/>
+          </a:prstGeom>
+        </p:spPr>
+      </p:pic>
+      <p:grpSp>
+        <p:nvGrpSpPr>
+          <p:cNvPr id="48" name="Group 47">
+            <a:extLst>
+              <a:ext uri="{FF2B5EF4-FFF2-40B4-BE49-F238E27FC236}">
+                <a16:creationId xmlns:a16="http://schemas.microsoft.com/office/drawing/2014/main" id="{57689BA5-6C16-FEED-32AD-D6DE6D833896}"/>
+              </a:ext>
+            </a:extLst>
+          </p:cNvPr>
+          <p:cNvGrpSpPr/>
+          <p:nvPr/>
+        </p:nvGrpSpPr>
+        <p:grpSpPr>
+          <a:xfrm>
+            <a:off x="6732240" y="2564904"/>
+            <a:ext cx="1728192" cy="1728192"/>
+            <a:chOff x="6660232" y="4581128"/>
+            <a:chExt cx="1728192" cy="1728192"/>
+          </a:xfrm>
+        </p:grpSpPr>
+        <p:pic>
+          <p:nvPicPr>
+            <p:cNvPr id="49" name="Picture 48" descr="10-109406_button-media-player-icon-icon-play-pause-stop.png">
+              <a:extLst>
+                <a:ext uri="{FF2B5EF4-FFF2-40B4-BE49-F238E27FC236}">
+                  <a16:creationId xmlns:a16="http://schemas.microsoft.com/office/drawing/2014/main" id="{1E791652-A769-A806-0CF8-4FCF89466AAF}"/>
+                </a:ext>
+              </a:extLst>
+            </p:cNvPr>
+            <p:cNvPicPr>
+              <a:picLocks noChangeAspect="1"/>
+            </p:cNvPicPr>
+            <p:nvPr/>
+          </p:nvPicPr>
+          <p:blipFill>
+            <a:blip r:embed="rId2" cstate="print">
+              <a:duotone>
+                <a:schemeClr val="accent6">
+                  <a:shade val="45000"/>
+                  <a:satMod val="135000"/>
+                </a:schemeClr>
+                <a:prstClr val="white"/>
+              </a:duotone>
+            </a:blip>
+            <a:srcRect l="75493" t="67480" r="3410" b="6301"/>
+            <a:stretch>
+              <a:fillRect/>
+            </a:stretch>
+          </p:blipFill>
+          <p:spPr>
+            <a:xfrm>
+              <a:off x="6660232" y="4581128"/>
+              <a:ext cx="1728192" cy="1728192"/>
+            </a:xfrm>
+            <a:prstGeom prst="rect">
+              <a:avLst/>
+            </a:prstGeom>
+          </p:spPr>
+        </p:pic>
+        <p:pic>
+          <p:nvPicPr>
+            <p:cNvPr id="50" name="Picture 49" descr="10-109406_button-media-player-icon-icon-play-pause-stop.png">
+              <a:extLst>
+                <a:ext uri="{FF2B5EF4-FFF2-40B4-BE49-F238E27FC236}">
+                  <a16:creationId xmlns:a16="http://schemas.microsoft.com/office/drawing/2014/main" id="{A2886219-9FB3-9162-569E-609F62D8354E}"/>
+                </a:ext>
+              </a:extLst>
+            </p:cNvPr>
+            <p:cNvPicPr>
+              <a:picLocks noChangeAspect="1"/>
+            </p:cNvPicPr>
+            <p:nvPr/>
+          </p:nvPicPr>
+          <p:blipFill>
+            <a:blip r:embed="rId2" cstate="print">
+              <a:duotone>
+                <a:schemeClr val="accent6">
+                  <a:shade val="45000"/>
+                  <a:satMod val="135000"/>
+                </a:schemeClr>
+                <a:prstClr val="white"/>
+              </a:duotone>
+            </a:blip>
+            <a:srcRect l="81646" t="74035" r="8684" b="12856"/>
+            <a:stretch>
+              <a:fillRect/>
+            </a:stretch>
+          </p:blipFill>
+          <p:spPr>
+            <a:xfrm rot="2700000">
+              <a:off x="7137770" y="5003690"/>
+              <a:ext cx="792088" cy="864096"/>
+            </a:xfrm>
+            <a:prstGeom prst="rect">
+              <a:avLst/>
+            </a:prstGeom>
+          </p:spPr>
+        </p:pic>
+      </p:grpSp>
     </p:spTree>
+  </p:cSld>
+  <p:clrMapOvr>
+    <a:masterClrMapping/>
+  </p:clrMapOvr>
+</p:sld>
+</file>
+
+<file path=ppt/slides/slide4.xml><?xml version="1.0" encoding="utf-8"?>
+<p:sld xmlns:a="http://schemas.openxmlformats.org/drawingml/2006/main" xmlns:r="http://schemas.openxmlformats.org/officeDocument/2006/relationships" xmlns:p="http://schemas.openxmlformats.org/presentationml/2006/main">
+  <p:cSld>
+    <p:spTree>
+      <p:nvGrpSpPr>
+        <p:cNvPr id="1" name=""/>
+        <p:cNvGrpSpPr/>
+        <p:nvPr/>
+      </p:nvGrpSpPr>
+      <p:grpSpPr>
+        <a:xfrm>
+          <a:off x="0" y="0"/>
+          <a:ext cx="0" cy="0"/>
+          <a:chOff x="0" y="0"/>
+          <a:chExt cx="0" cy="0"/>
+        </a:xfrm>
+      </p:grpSpPr>
+      <p:grpSp>
+        <p:nvGrpSpPr>
+          <p:cNvPr id="8" name="Group 7">
+            <a:extLst>
+              <a:ext uri="{FF2B5EF4-FFF2-40B4-BE49-F238E27FC236}">
+                <a16:creationId xmlns:a16="http://schemas.microsoft.com/office/drawing/2014/main" id="{BBD9BCAE-4998-2D34-F26C-8BF51C218578}"/>
+              </a:ext>
+            </a:extLst>
+          </p:cNvPr>
+          <p:cNvGrpSpPr/>
+          <p:nvPr/>
+        </p:nvGrpSpPr>
+        <p:grpSpPr>
+          <a:xfrm>
+            <a:off x="827584" y="548680"/>
+            <a:ext cx="1584176" cy="1656184"/>
+            <a:chOff x="827584" y="548680"/>
+            <a:chExt cx="1584176" cy="1656184"/>
+          </a:xfrm>
+        </p:grpSpPr>
+        <p:pic>
+          <p:nvPicPr>
+            <p:cNvPr id="4" name="Picture 3" descr="10-109406_button-media-player-icon-icon-play-pause-stop.png">
+              <a:extLst>
+                <a:ext uri="{FF2B5EF4-FFF2-40B4-BE49-F238E27FC236}">
+                  <a16:creationId xmlns:a16="http://schemas.microsoft.com/office/drawing/2014/main" id="{D2DE4910-45D2-9F57-09BB-EF07DA685261}"/>
+                </a:ext>
+              </a:extLst>
+            </p:cNvPr>
+            <p:cNvPicPr>
+              <a:picLocks noChangeAspect="1"/>
+            </p:cNvPicPr>
+            <p:nvPr/>
+          </p:nvPicPr>
+          <p:blipFill rotWithShape="1">
+            <a:blip r:embed="rId2" cstate="print">
+              <a:duotone>
+                <a:schemeClr val="accent6">
+                  <a:shade val="45000"/>
+                  <a:satMod val="135000"/>
+                </a:schemeClr>
+                <a:prstClr val="white"/>
+              </a:duotone>
+            </a:blip>
+            <a:srcRect l="4289" t="6301" r="76372" b="68572"/>
+            <a:stretch/>
+          </p:blipFill>
+          <p:spPr>
+            <a:xfrm>
+              <a:off x="827584" y="548680"/>
+              <a:ext cx="1584176" cy="1656184"/>
+            </a:xfrm>
+            <a:prstGeom prst="rect">
+              <a:avLst/>
+            </a:prstGeom>
+          </p:spPr>
+        </p:pic>
+        <p:sp>
+          <p:nvSpPr>
+            <p:cNvPr id="6" name="Rectangle 5">
+              <a:extLst>
+                <a:ext uri="{FF2B5EF4-FFF2-40B4-BE49-F238E27FC236}">
+                  <a16:creationId xmlns:a16="http://schemas.microsoft.com/office/drawing/2014/main" id="{F189FA58-ED44-D0BF-FA72-66CFE3D3FD19}"/>
+                </a:ext>
+              </a:extLst>
+            </p:cNvPr>
+            <p:cNvSpPr/>
+            <p:nvPr/>
+          </p:nvSpPr>
+          <p:spPr>
+            <a:xfrm>
+              <a:off x="1403648" y="836712"/>
+              <a:ext cx="348519" cy="648072"/>
+            </a:xfrm>
+            <a:prstGeom prst="rect">
+              <a:avLst/>
+            </a:prstGeom>
+            <a:solidFill>
+              <a:schemeClr val="bg1"/>
+            </a:solidFill>
+            <a:ln>
+              <a:solidFill>
+                <a:schemeClr val="bg1"/>
+              </a:solidFill>
+            </a:ln>
+          </p:spPr>
+          <p:style>
+            <a:lnRef idx="2">
+              <a:schemeClr val="accent1">
+                <a:shade val="50000"/>
+              </a:schemeClr>
+            </a:lnRef>
+            <a:fillRef idx="1">
+              <a:schemeClr val="accent1"/>
+            </a:fillRef>
+            <a:effectRef idx="0">
+              <a:schemeClr val="accent1"/>
+            </a:effectRef>
+            <a:fontRef idx="minor">
+              <a:schemeClr val="lt1"/>
+            </a:fontRef>
+          </p:style>
+          <p:txBody>
+            <a:bodyPr rtlCol="0" anchor="ctr"/>
+            <a:lstStyle/>
+            <a:p>
+              <a:pPr algn="ctr"/>
+              <a:endParaRPr lang="en-CA"/>
+            </a:p>
+          </p:txBody>
+        </p:sp>
+        <p:sp>
+          <p:nvSpPr>
+            <p:cNvPr id="5" name="Right Triangle 4">
+              <a:extLst>
+                <a:ext uri="{FF2B5EF4-FFF2-40B4-BE49-F238E27FC236}">
+                  <a16:creationId xmlns:a16="http://schemas.microsoft.com/office/drawing/2014/main" id="{5EE5AFBA-81A0-B57D-3420-21A81FA75A19}"/>
+                </a:ext>
+              </a:extLst>
+            </p:cNvPr>
+            <p:cNvSpPr/>
+            <p:nvPr/>
+          </p:nvSpPr>
+          <p:spPr>
+            <a:xfrm rot="2435509">
+              <a:off x="1594041" y="908688"/>
+              <a:ext cx="249723" cy="317750"/>
+            </a:xfrm>
+            <a:prstGeom prst="rtTriangle">
+              <a:avLst/>
+            </a:prstGeom>
+            <a:solidFill>
+              <a:srgbClr val="D69560"/>
+            </a:solidFill>
+            <a:ln>
+              <a:solidFill>
+                <a:srgbClr val="D69560"/>
+              </a:solidFill>
+            </a:ln>
+          </p:spPr>
+          <p:style>
+            <a:lnRef idx="2">
+              <a:schemeClr val="accent1">
+                <a:shade val="50000"/>
+              </a:schemeClr>
+            </a:lnRef>
+            <a:fillRef idx="1">
+              <a:schemeClr val="accent1"/>
+            </a:fillRef>
+            <a:effectRef idx="0">
+              <a:schemeClr val="accent1"/>
+            </a:effectRef>
+            <a:fontRef idx="minor">
+              <a:schemeClr val="lt1"/>
+            </a:fontRef>
+          </p:style>
+          <p:txBody>
+            <a:bodyPr rtlCol="0" anchor="ctr"/>
+            <a:lstStyle/>
+            <a:p>
+              <a:pPr algn="ctr"/>
+              <a:endParaRPr lang="en-CA" dirty="0"/>
+            </a:p>
+          </p:txBody>
+        </p:sp>
+        <p:sp>
+          <p:nvSpPr>
+            <p:cNvPr id="7" name="Rectangle 6">
+              <a:extLst>
+                <a:ext uri="{FF2B5EF4-FFF2-40B4-BE49-F238E27FC236}">
+                  <a16:creationId xmlns:a16="http://schemas.microsoft.com/office/drawing/2014/main" id="{DFD2769A-90EA-ED42-A209-5E5FB151A540}"/>
+                </a:ext>
+              </a:extLst>
+            </p:cNvPr>
+            <p:cNvSpPr/>
+            <p:nvPr/>
+          </p:nvSpPr>
+          <p:spPr>
+            <a:xfrm rot="866630">
+              <a:off x="1680159" y="1042293"/>
+              <a:ext cx="144016" cy="138689"/>
+            </a:xfrm>
+            <a:prstGeom prst="rect">
+              <a:avLst/>
+            </a:prstGeom>
+            <a:solidFill>
+              <a:srgbClr val="D69560"/>
+            </a:solidFill>
+            <a:ln>
+              <a:solidFill>
+                <a:srgbClr val="D69560"/>
+              </a:solidFill>
+            </a:ln>
+          </p:spPr>
+          <p:style>
+            <a:lnRef idx="2">
+              <a:schemeClr val="accent1">
+                <a:shade val="50000"/>
+              </a:schemeClr>
+            </a:lnRef>
+            <a:fillRef idx="1">
+              <a:schemeClr val="accent1"/>
+            </a:fillRef>
+            <a:effectRef idx="0">
+              <a:schemeClr val="accent1"/>
+            </a:effectRef>
+            <a:fontRef idx="minor">
+              <a:schemeClr val="lt1"/>
+            </a:fontRef>
+          </p:style>
+          <p:txBody>
+            <a:bodyPr rtlCol="0" anchor="ctr"/>
+            <a:lstStyle/>
+            <a:p>
+              <a:pPr algn="ctr"/>
+              <a:endParaRPr lang="en-CA"/>
+            </a:p>
+          </p:txBody>
+        </p:sp>
+      </p:grpSp>
+    </p:spTree>
+    <p:extLst>
+      <p:ext uri="{BB962C8B-B14F-4D97-AF65-F5344CB8AC3E}">
+        <p14:creationId xmlns:p14="http://schemas.microsoft.com/office/powerpoint/2010/main" val="883016848"/>
+      </p:ext>
+    </p:extLst>
   </p:cSld>
   <p:clrMapOvr>
     <a:masterClrMapping/>

</xml_diff>